<commit_message>
Embed speaker notes in workshop deck
</commit_message>
<xml_diff>
--- a/presentations/harness-engineering-workshop.pptx
+++ b/presentations/harness-engineering-workshop.pptx
@@ -462,7 +462,7 @@
 </file>
 
 <file path=ppt/notesSlides/notesSlide1.xml><?xml version="1.0" encoding="utf-8"?>
-<p:notes xmlns:p="http://schemas.openxmlformats.org/presentationml/2006/main">
+<p:notes xmlns:a="http://schemas.openxmlformats.org/drawingml/2006/main" xmlns:p="http://schemas.openxmlformats.org/presentationml/2006/main">
   <p:cSld>
     <p:spTree>
       <p:nvGrpSpPr>
@@ -471,13 +471,13 @@
         <p:nvPr/>
       </p:nvGrpSpPr>
       <p:grpSpPr>
-        <a:xfrm xmlns:a="http://schemas.openxmlformats.org/drawingml/2006/main"/>
+        <a:xfrm/>
       </p:grpSpPr>
       <p:sp>
         <p:nvSpPr>
           <p:cNvPr id="2" name="Slide Image Placeholder 1"/>
           <p:cNvSpPr>
-            <a:spLocks xmlns:a="http://schemas.openxmlformats.org/drawingml/2006/main" noGrp="1"/>
+            <a:spLocks noGrp="1"/>
           </p:cNvSpPr>
           <p:nvPr>
             <p:ph type="sldImg" idx="0"/>
@@ -489,7 +489,7 @@
         <p:nvSpPr>
           <p:cNvPr id="3" name="Notes Placeholder 2"/>
           <p:cNvSpPr>
-            <a:spLocks xmlns:a="http://schemas.openxmlformats.org/drawingml/2006/main" noGrp="1"/>
+            <a:spLocks noGrp="1"/>
           </p:cNvSpPr>
           <p:nvPr>
             <p:ph type="body" idx="1"/>
@@ -497,16 +497,27 @@
         </p:nvSpPr>
         <p:spPr/>
         <p:txBody>
-          <a:bodyPr xmlns:a="http://schemas.openxmlformats.org/drawingml/2006/main"/>
-          <a:lstStyle xmlns:a="http://schemas.openxmlformats.org/drawingml/2006/main"/>
-          <a:p xmlns:a="http://schemas.openxmlformats.org/drawingml/2006/main"/>
+          <a:bodyPr/>
+          <a:lstStyle/>
+          <a:p>
+            <a:r>
+              <a:rPr lang="en-US"/>
+              <a:t>Harness engineering is the work around the agent.</a:t>
+            </a:r>
+          </a:p>
+          <a:p>
+            <a:r>
+              <a:rPr lang="en-US"/>
+              <a:t>Open by separating the model from the system around it. The agent may write the code, but the harness gives it context, tools, checks, and boundaries.</a:t>
+            </a:r>
+          </a:p>
         </p:txBody>
       </p:sp>
       <p:sp>
         <p:nvSpPr>
           <p:cNvPr id="4" name="Slide Number Placeholder 3"/>
           <p:cNvSpPr>
-            <a:spLocks xmlns:a="http://schemas.openxmlformats.org/drawingml/2006/main" noGrp="1"/>
+            <a:spLocks noGrp="1"/>
           </p:cNvSpPr>
           <p:nvPr>
             <p:ph type="sldNum" idx="5"/>
@@ -514,21 +525,21 @@
         </p:nvSpPr>
         <p:spPr/>
         <p:txBody>
-          <a:bodyPr xmlns:a="http://schemas.openxmlformats.org/drawingml/2006/main"/>
-          <a:lstStyle xmlns:a="http://schemas.openxmlformats.org/drawingml/2006/main"/>
-          <a:p xmlns:a="http://schemas.openxmlformats.org/drawingml/2006/main"/>
+          <a:bodyPr/>
+          <a:lstStyle/>
+          <a:p/>
         </p:txBody>
       </p:sp>
     </p:spTree>
   </p:cSld>
   <p:clrMapOvr>
-    <a:masterClrMapping xmlns:a="http://schemas.openxmlformats.org/drawingml/2006/main"/>
+    <a:masterClrMapping/>
   </p:clrMapOvr>
 </p:notes>
 </file>
 
 <file path=ppt/notesSlides/notesSlide10.xml><?xml version="1.0" encoding="utf-8"?>
-<p:notes xmlns:p="http://schemas.openxmlformats.org/presentationml/2006/main">
+<p:notes xmlns:a="http://schemas.openxmlformats.org/drawingml/2006/main" xmlns:p="http://schemas.openxmlformats.org/presentationml/2006/main">
   <p:cSld>
     <p:spTree>
       <p:nvGrpSpPr>
@@ -537,13 +548,13 @@
         <p:nvPr/>
       </p:nvGrpSpPr>
       <p:grpSpPr>
-        <a:xfrm xmlns:a="http://schemas.openxmlformats.org/drawingml/2006/main"/>
+        <a:xfrm/>
       </p:grpSpPr>
       <p:sp>
         <p:nvSpPr>
           <p:cNvPr id="2" name="Slide Image Placeholder 1"/>
           <p:cNvSpPr>
-            <a:spLocks xmlns:a="http://schemas.openxmlformats.org/drawingml/2006/main" noGrp="1"/>
+            <a:spLocks noGrp="1"/>
           </p:cNvSpPr>
           <p:nvPr>
             <p:ph type="sldImg" idx="0"/>
@@ -555,7 +566,7 @@
         <p:nvSpPr>
           <p:cNvPr id="3" name="Notes Placeholder 2"/>
           <p:cNvSpPr>
-            <a:spLocks xmlns:a="http://schemas.openxmlformats.org/drawingml/2006/main" noGrp="1"/>
+            <a:spLocks noGrp="1"/>
           </p:cNvSpPr>
           <p:nvPr>
             <p:ph type="body" idx="1"/>
@@ -563,16 +574,27 @@
         </p:nvSpPr>
         <p:spPr/>
         <p:txBody>
-          <a:bodyPr xmlns:a="http://schemas.openxmlformats.org/drawingml/2006/main"/>
-          <a:lstStyle xmlns:a="http://schemas.openxmlformats.org/drawingml/2006/main"/>
-          <a:p xmlns:a="http://schemas.openxmlformats.org/drawingml/2006/main"/>
+          <a:bodyPr/>
+          <a:lstStyle/>
+          <a:p>
+            <a:r>
+              <a:rPr lang="en-US"/>
+              <a:t>Build the harness in layers, not in one heroic rewrite.</a:t>
+            </a:r>
+          </a:p>
+          <a:p>
+            <a:r>
+              <a:rPr lang="en-US"/>
+              <a:t>Give the team a practical path: first instructions and one command, then CI and runbooks, then architecture checks and recurring cleanup.</a:t>
+            </a:r>
+          </a:p>
         </p:txBody>
       </p:sp>
       <p:sp>
         <p:nvSpPr>
           <p:cNvPr id="4" name="Slide Number Placeholder 3"/>
           <p:cNvSpPr>
-            <a:spLocks xmlns:a="http://schemas.openxmlformats.org/drawingml/2006/main" noGrp="1"/>
+            <a:spLocks noGrp="1"/>
           </p:cNvSpPr>
           <p:nvPr>
             <p:ph type="sldNum" idx="5"/>
@@ -580,21 +602,21 @@
         </p:nvSpPr>
         <p:spPr/>
         <p:txBody>
-          <a:bodyPr xmlns:a="http://schemas.openxmlformats.org/drawingml/2006/main"/>
-          <a:lstStyle xmlns:a="http://schemas.openxmlformats.org/drawingml/2006/main"/>
-          <a:p xmlns:a="http://schemas.openxmlformats.org/drawingml/2006/main"/>
+          <a:bodyPr/>
+          <a:lstStyle/>
+          <a:p/>
         </p:txBody>
       </p:sp>
     </p:spTree>
   </p:cSld>
   <p:clrMapOvr>
-    <a:masterClrMapping xmlns:a="http://schemas.openxmlformats.org/drawingml/2006/main"/>
+    <a:masterClrMapping/>
   </p:clrMapOvr>
 </p:notes>
 </file>
 
 <file path=ppt/notesSlides/notesSlide11.xml><?xml version="1.0" encoding="utf-8"?>
-<p:notes xmlns:p="http://schemas.openxmlformats.org/presentationml/2006/main">
+<p:notes xmlns:a="http://schemas.openxmlformats.org/drawingml/2006/main" xmlns:p="http://schemas.openxmlformats.org/presentationml/2006/main">
   <p:cSld>
     <p:spTree>
       <p:nvGrpSpPr>
@@ -603,13 +625,13 @@
         <p:nvPr/>
       </p:nvGrpSpPr>
       <p:grpSpPr>
-        <a:xfrm xmlns:a="http://schemas.openxmlformats.org/drawingml/2006/main"/>
+        <a:xfrm/>
       </p:grpSpPr>
       <p:sp>
         <p:nvSpPr>
           <p:cNvPr id="2" name="Slide Image Placeholder 1"/>
           <p:cNvSpPr>
-            <a:spLocks xmlns:a="http://schemas.openxmlformats.org/drawingml/2006/main" noGrp="1"/>
+            <a:spLocks noGrp="1"/>
           </p:cNvSpPr>
           <p:nvPr>
             <p:ph type="sldImg" idx="0"/>
@@ -621,7 +643,7 @@
         <p:nvSpPr>
           <p:cNvPr id="3" name="Notes Placeholder 2"/>
           <p:cNvSpPr>
-            <a:spLocks xmlns:a="http://schemas.openxmlformats.org/drawingml/2006/main" noGrp="1"/>
+            <a:spLocks noGrp="1"/>
           </p:cNvSpPr>
           <p:nvPr>
             <p:ph type="body" idx="1"/>
@@ -629,16 +651,27 @@
         </p:nvSpPr>
         <p:spPr/>
         <p:txBody>
-          <a:bodyPr xmlns:a="http://schemas.openxmlformats.org/drawingml/2006/main"/>
-          <a:lstStyle xmlns:a="http://schemas.openxmlformats.org/drawingml/2006/main"/>
-          <a:p xmlns:a="http://schemas.openxmlformats.org/drawingml/2006/main"/>
+          <a:bodyPr/>
+          <a:lstStyle/>
+          <a:p>
+            <a:r>
+              <a:rPr lang="en-US"/>
+              <a:t>Less prompt ritual. More engineering leverage.</a:t>
+            </a:r>
+          </a:p>
+          <a:p>
+            <a:r>
+              <a:rPr lang="en-US"/>
+              <a:t>Close with the operating principle: treat bad agent output as feedback about the harness. Improve the system, not just the prompt.</a:t>
+            </a:r>
+          </a:p>
         </p:txBody>
       </p:sp>
       <p:sp>
         <p:nvSpPr>
           <p:cNvPr id="4" name="Slide Number Placeholder 3"/>
           <p:cNvSpPr>
-            <a:spLocks xmlns:a="http://schemas.openxmlformats.org/drawingml/2006/main" noGrp="1"/>
+            <a:spLocks noGrp="1"/>
           </p:cNvSpPr>
           <p:nvPr>
             <p:ph type="sldNum" idx="5"/>
@@ -646,21 +679,21 @@
         </p:nvSpPr>
         <p:spPr/>
         <p:txBody>
-          <a:bodyPr xmlns:a="http://schemas.openxmlformats.org/drawingml/2006/main"/>
-          <a:lstStyle xmlns:a="http://schemas.openxmlformats.org/drawingml/2006/main"/>
-          <a:p xmlns:a="http://schemas.openxmlformats.org/drawingml/2006/main"/>
+          <a:bodyPr/>
+          <a:lstStyle/>
+          <a:p/>
         </p:txBody>
       </p:sp>
     </p:spTree>
   </p:cSld>
   <p:clrMapOvr>
-    <a:masterClrMapping xmlns:a="http://schemas.openxmlformats.org/drawingml/2006/main"/>
+    <a:masterClrMapping/>
   </p:clrMapOvr>
 </p:notes>
 </file>
 
 <file path=ppt/notesSlides/notesSlide2.xml><?xml version="1.0" encoding="utf-8"?>
-<p:notes xmlns:p="http://schemas.openxmlformats.org/presentationml/2006/main">
+<p:notes xmlns:a="http://schemas.openxmlformats.org/drawingml/2006/main" xmlns:p="http://schemas.openxmlformats.org/presentationml/2006/main">
   <p:cSld>
     <p:spTree>
       <p:nvGrpSpPr>
@@ -669,13 +702,13 @@
         <p:nvPr/>
       </p:nvGrpSpPr>
       <p:grpSpPr>
-        <a:xfrm xmlns:a="http://schemas.openxmlformats.org/drawingml/2006/main"/>
+        <a:xfrm/>
       </p:grpSpPr>
       <p:sp>
         <p:nvSpPr>
           <p:cNvPr id="2" name="Slide Image Placeholder 1"/>
           <p:cNvSpPr>
-            <a:spLocks xmlns:a="http://schemas.openxmlformats.org/drawingml/2006/main" noGrp="1"/>
+            <a:spLocks noGrp="1"/>
           </p:cNvSpPr>
           <p:nvPr>
             <p:ph type="sldImg" idx="0"/>
@@ -687,7 +720,7 @@
         <p:nvSpPr>
           <p:cNvPr id="3" name="Notes Placeholder 2"/>
           <p:cNvSpPr>
-            <a:spLocks xmlns:a="http://schemas.openxmlformats.org/drawingml/2006/main" noGrp="1"/>
+            <a:spLocks noGrp="1"/>
           </p:cNvSpPr>
           <p:nvPr>
             <p:ph type="body" idx="1"/>
@@ -695,16 +728,27 @@
         </p:nvSpPr>
         <p:spPr/>
         <p:txBody>
-          <a:bodyPr xmlns:a="http://schemas.openxmlformats.org/drawingml/2006/main"/>
-          <a:lstStyle xmlns:a="http://schemas.openxmlformats.org/drawingml/2006/main"/>
-          <a:p xmlns:a="http://schemas.openxmlformats.org/drawingml/2006/main"/>
+          <a:bodyPr/>
+          <a:lstStyle/>
+          <a:p>
+            <a:r>
+              <a:rPr lang="en-US"/>
+              <a:t>A harness gives an agent five kinds of traction.</a:t>
+            </a:r>
+          </a:p>
+          <a:p>
+            <a:r>
+              <a:rPr lang="en-US"/>
+              <a:t>Walk through the five layers: context, execution, feedback, governance, and memory. Emphasize that each layer reduces ambiguity for both humans and agents.</a:t>
+            </a:r>
+          </a:p>
         </p:txBody>
       </p:sp>
       <p:sp>
         <p:nvSpPr>
           <p:cNvPr id="4" name="Slide Number Placeholder 3"/>
           <p:cNvSpPr>
-            <a:spLocks xmlns:a="http://schemas.openxmlformats.org/drawingml/2006/main" noGrp="1"/>
+            <a:spLocks noGrp="1"/>
           </p:cNvSpPr>
           <p:nvPr>
             <p:ph type="sldNum" idx="5"/>
@@ -712,21 +756,21 @@
         </p:nvSpPr>
         <p:spPr/>
         <p:txBody>
-          <a:bodyPr xmlns:a="http://schemas.openxmlformats.org/drawingml/2006/main"/>
-          <a:lstStyle xmlns:a="http://schemas.openxmlformats.org/drawingml/2006/main"/>
-          <a:p xmlns:a="http://schemas.openxmlformats.org/drawingml/2006/main"/>
+          <a:bodyPr/>
+          <a:lstStyle/>
+          <a:p/>
         </p:txBody>
       </p:sp>
     </p:spTree>
   </p:cSld>
   <p:clrMapOvr>
-    <a:masterClrMapping xmlns:a="http://schemas.openxmlformats.org/drawingml/2006/main"/>
+    <a:masterClrMapping/>
   </p:clrMapOvr>
 </p:notes>
 </file>
 
 <file path=ppt/notesSlides/notesSlide3.xml><?xml version="1.0" encoding="utf-8"?>
-<p:notes xmlns:p="http://schemas.openxmlformats.org/presentationml/2006/main">
+<p:notes xmlns:a="http://schemas.openxmlformats.org/drawingml/2006/main" xmlns:p="http://schemas.openxmlformats.org/presentationml/2006/main">
   <p:cSld>
     <p:spTree>
       <p:nvGrpSpPr>
@@ -735,13 +779,13 @@
         <p:nvPr/>
       </p:nvGrpSpPr>
       <p:grpSpPr>
-        <a:xfrm xmlns:a="http://schemas.openxmlformats.org/drawingml/2006/main"/>
+        <a:xfrm/>
       </p:grpSpPr>
       <p:sp>
         <p:nvSpPr>
           <p:cNvPr id="2" name="Slide Image Placeholder 1"/>
           <p:cNvSpPr>
-            <a:spLocks xmlns:a="http://schemas.openxmlformats.org/drawingml/2006/main" noGrp="1"/>
+            <a:spLocks noGrp="1"/>
           </p:cNvSpPr>
           <p:nvPr>
             <p:ph type="sldImg" idx="0"/>
@@ -753,7 +797,7 @@
         <p:nvSpPr>
           <p:cNvPr id="3" name="Notes Placeholder 2"/>
           <p:cNvSpPr>
-            <a:spLocks xmlns:a="http://schemas.openxmlformats.org/drawingml/2006/main" noGrp="1"/>
+            <a:spLocks noGrp="1"/>
           </p:cNvSpPr>
           <p:nvPr>
             <p:ph type="body" idx="1"/>
@@ -761,16 +805,27 @@
         </p:nvSpPr>
         <p:spPr/>
         <p:txBody>
-          <a:bodyPr xmlns:a="http://schemas.openxmlformats.org/drawingml/2006/main"/>
-          <a:lstStyle xmlns:a="http://schemas.openxmlformats.org/drawingml/2006/main"/>
-          <a:p xmlns:a="http://schemas.openxmlformats.org/drawingml/2006/main"/>
+          <a:bodyPr/>
+          <a:lstStyle/>
+          <a:p>
+            <a:r>
+              <a:rPr lang="en-US"/>
+              <a:t>The prompt gets shorter as the harness gets stronger.</a:t>
+            </a:r>
+          </a:p>
+          <a:p>
+            <a:r>
+              <a:rPr lang="en-US"/>
+              <a:t>Say the goal clearly: durable instructions should move out of prompts and into the repo. The best demo prompt is simply `Complete tasks/01-add-sla-classification.md`.</a:t>
+            </a:r>
+          </a:p>
         </p:txBody>
       </p:sp>
       <p:sp>
         <p:nvSpPr>
           <p:cNvPr id="4" name="Slide Number Placeholder 3"/>
           <p:cNvSpPr>
-            <a:spLocks xmlns:a="http://schemas.openxmlformats.org/drawingml/2006/main" noGrp="1"/>
+            <a:spLocks noGrp="1"/>
           </p:cNvSpPr>
           <p:nvPr>
             <p:ph type="sldNum" idx="5"/>
@@ -778,21 +833,21 @@
         </p:nvSpPr>
         <p:spPr/>
         <p:txBody>
-          <a:bodyPr xmlns:a="http://schemas.openxmlformats.org/drawingml/2006/main"/>
-          <a:lstStyle xmlns:a="http://schemas.openxmlformats.org/drawingml/2006/main"/>
-          <a:p xmlns:a="http://schemas.openxmlformats.org/drawingml/2006/main"/>
+          <a:bodyPr/>
+          <a:lstStyle/>
+          <a:p/>
         </p:txBody>
       </p:sp>
     </p:spTree>
   </p:cSld>
   <p:clrMapOvr>
-    <a:masterClrMapping xmlns:a="http://schemas.openxmlformats.org/drawingml/2006/main"/>
+    <a:masterClrMapping/>
   </p:clrMapOvr>
 </p:notes>
 </file>
 
 <file path=ppt/notesSlides/notesSlide4.xml><?xml version="1.0" encoding="utf-8"?>
-<p:notes xmlns:p="http://schemas.openxmlformats.org/presentationml/2006/main">
+<p:notes xmlns:a="http://schemas.openxmlformats.org/drawingml/2006/main" xmlns:p="http://schemas.openxmlformats.org/presentationml/2006/main">
   <p:cSld>
     <p:spTree>
       <p:nvGrpSpPr>
@@ -801,13 +856,13 @@
         <p:nvPr/>
       </p:nvGrpSpPr>
       <p:grpSpPr>
-        <a:xfrm xmlns:a="http://schemas.openxmlformats.org/drawingml/2006/main"/>
+        <a:xfrm/>
       </p:grpSpPr>
       <p:sp>
         <p:nvSpPr>
           <p:cNvPr id="2" name="Slide Image Placeholder 1"/>
           <p:cNvSpPr>
-            <a:spLocks xmlns:a="http://schemas.openxmlformats.org/drawingml/2006/main" noGrp="1"/>
+            <a:spLocks noGrp="1"/>
           </p:cNvSpPr>
           <p:nvPr>
             <p:ph type="sldImg" idx="0"/>
@@ -819,7 +874,7 @@
         <p:nvSpPr>
           <p:cNvPr id="3" name="Notes Placeholder 2"/>
           <p:cNvSpPr>
-            <a:spLocks xmlns:a="http://schemas.openxmlformats.org/drawingml/2006/main" noGrp="1"/>
+            <a:spLocks noGrp="1"/>
           </p:cNvSpPr>
           <p:nvPr>
             <p:ph type="body" idx="1"/>
@@ -827,16 +882,27 @@
         </p:nvSpPr>
         <p:spPr/>
         <p:txBody>
-          <a:bodyPr xmlns:a="http://schemas.openxmlformats.org/drawingml/2006/main"/>
-          <a:lstStyle xmlns:a="http://schemas.openxmlformats.org/drawingml/2006/main"/>
-          <a:p xmlns:a="http://schemas.openxmlformats.org/drawingml/2006/main"/>
+          <a:bodyPr/>
+          <a:lstStyle/>
+          <a:p>
+            <a:r>
+              <a:rPr lang="en-US"/>
+              <a:t>Our demo repo keeps the app tiny and the harness visible.</a:t>
+            </a:r>
+          </a:p>
+          <a:p>
+            <a:r>
+              <a:rPr lang="en-US"/>
+              <a:t>Explain that the app is intentionally small: a ticket router. The repo is the teaching object because the harness is easy to inspect.</a:t>
+            </a:r>
+          </a:p>
         </p:txBody>
       </p:sp>
       <p:sp>
         <p:nvSpPr>
           <p:cNvPr id="4" name="Slide Number Placeholder 3"/>
           <p:cNvSpPr>
-            <a:spLocks xmlns:a="http://schemas.openxmlformats.org/drawingml/2006/main" noGrp="1"/>
+            <a:spLocks noGrp="1"/>
           </p:cNvSpPr>
           <p:nvPr>
             <p:ph type="sldNum" idx="5"/>
@@ -844,21 +910,21 @@
         </p:nvSpPr>
         <p:spPr/>
         <p:txBody>
-          <a:bodyPr xmlns:a="http://schemas.openxmlformats.org/drawingml/2006/main"/>
-          <a:lstStyle xmlns:a="http://schemas.openxmlformats.org/drawingml/2006/main"/>
-          <a:p xmlns:a="http://schemas.openxmlformats.org/drawingml/2006/main"/>
+          <a:bodyPr/>
+          <a:lstStyle/>
+          <a:p/>
         </p:txBody>
       </p:sp>
     </p:spTree>
   </p:cSld>
   <p:clrMapOvr>
-    <a:masterClrMapping xmlns:a="http://schemas.openxmlformats.org/drawingml/2006/main"/>
+    <a:masterClrMapping/>
   </p:clrMapOvr>
 </p:notes>
 </file>
 
 <file path=ppt/notesSlides/notesSlide5.xml><?xml version="1.0" encoding="utf-8"?>
-<p:notes xmlns:p="http://schemas.openxmlformats.org/presentationml/2006/main">
+<p:notes xmlns:a="http://schemas.openxmlformats.org/drawingml/2006/main" xmlns:p="http://schemas.openxmlformats.org/presentationml/2006/main">
   <p:cSld>
     <p:spTree>
       <p:nvGrpSpPr>
@@ -867,13 +933,13 @@
         <p:nvPr/>
       </p:nvGrpSpPr>
       <p:grpSpPr>
-        <a:xfrm xmlns:a="http://schemas.openxmlformats.org/drawingml/2006/main"/>
+        <a:xfrm/>
       </p:grpSpPr>
       <p:sp>
         <p:nvSpPr>
           <p:cNvPr id="2" name="Slide Image Placeholder 1"/>
           <p:cNvSpPr>
-            <a:spLocks xmlns:a="http://schemas.openxmlformats.org/drawingml/2006/main" noGrp="1"/>
+            <a:spLocks noGrp="1"/>
           </p:cNvSpPr>
           <p:nvPr>
             <p:ph type="sldImg" idx="0"/>
@@ -885,7 +951,7 @@
         <p:nvSpPr>
           <p:cNvPr id="3" name="Notes Placeholder 2"/>
           <p:cNvSpPr>
-            <a:spLocks xmlns:a="http://schemas.openxmlformats.org/drawingml/2006/main" noGrp="1"/>
+            <a:spLocks noGrp="1"/>
           </p:cNvSpPr>
           <p:nvPr>
             <p:ph type="body" idx="1"/>
@@ -893,16 +959,27 @@
         </p:nvSpPr>
         <p:spPr/>
         <p:txBody>
-          <a:bodyPr xmlns:a="http://schemas.openxmlformats.org/drawingml/2006/main"/>
-          <a:lstStyle xmlns:a="http://schemas.openxmlformats.org/drawingml/2006/main"/>
-          <a:p xmlns:a="http://schemas.openxmlformats.org/drawingml/2006/main"/>
+          <a:bodyPr/>
+          <a:lstStyle/>
+          <a:p>
+            <a:r>
+              <a:rPr lang="en-US"/>
+              <a:t>The harness tells the agent what to read and where to change code.</a:t>
+            </a:r>
+          </a:p>
+          <a:p>
+            <a:r>
+              <a:rPr lang="en-US"/>
+              <a:t>Show how the task brief, `AGENTS.md`, architecture docs, router, and tests form a path. This narrows the search space before the agent edits.</a:t>
+            </a:r>
+          </a:p>
         </p:txBody>
       </p:sp>
       <p:sp>
         <p:nvSpPr>
           <p:cNvPr id="4" name="Slide Number Placeholder 3"/>
           <p:cNvSpPr>
-            <a:spLocks xmlns:a="http://schemas.openxmlformats.org/drawingml/2006/main" noGrp="1"/>
+            <a:spLocks noGrp="1"/>
           </p:cNvSpPr>
           <p:nvPr>
             <p:ph type="sldNum" idx="5"/>
@@ -910,21 +987,21 @@
         </p:nvSpPr>
         <p:spPr/>
         <p:txBody>
-          <a:bodyPr xmlns:a="http://schemas.openxmlformats.org/drawingml/2006/main"/>
-          <a:lstStyle xmlns:a="http://schemas.openxmlformats.org/drawingml/2006/main"/>
-          <a:p xmlns:a="http://schemas.openxmlformats.org/drawingml/2006/main"/>
+          <a:bodyPr/>
+          <a:lstStyle/>
+          <a:p/>
         </p:txBody>
       </p:sp>
     </p:spTree>
   </p:cSld>
   <p:clrMapOvr>
-    <a:masterClrMapping xmlns:a="http://schemas.openxmlformats.org/drawingml/2006/main"/>
+    <a:masterClrMapping/>
   </p:clrMapOvr>
 </p:notes>
 </file>
 
 <file path=ppt/notesSlides/notesSlide6.xml><?xml version="1.0" encoding="utf-8"?>
-<p:notes xmlns:p="http://schemas.openxmlformats.org/presentationml/2006/main">
+<p:notes xmlns:a="http://schemas.openxmlformats.org/drawingml/2006/main" xmlns:p="http://schemas.openxmlformats.org/presentationml/2006/main">
   <p:cSld>
     <p:spTree>
       <p:nvGrpSpPr>
@@ -933,13 +1010,13 @@
         <p:nvPr/>
       </p:nvGrpSpPr>
       <p:grpSpPr>
-        <a:xfrm xmlns:a="http://schemas.openxmlformats.org/drawingml/2006/main"/>
+        <a:xfrm/>
       </p:grpSpPr>
       <p:sp>
         <p:nvSpPr>
           <p:cNvPr id="2" name="Slide Image Placeholder 1"/>
           <p:cNvSpPr>
-            <a:spLocks xmlns:a="http://schemas.openxmlformats.org/drawingml/2006/main" noGrp="1"/>
+            <a:spLocks noGrp="1"/>
           </p:cNvSpPr>
           <p:nvPr>
             <p:ph type="sldImg" idx="0"/>
@@ -951,7 +1028,7 @@
         <p:nvSpPr>
           <p:cNvPr id="3" name="Notes Placeholder 2"/>
           <p:cNvSpPr>
-            <a:spLocks xmlns:a="http://schemas.openxmlformats.org/drawingml/2006/main" noGrp="1"/>
+            <a:spLocks noGrp="1"/>
           </p:cNvSpPr>
           <p:nvPr>
             <p:ph type="body" idx="1"/>
@@ -959,16 +1036,27 @@
         </p:nvSpPr>
         <p:spPr/>
         <p:txBody>
-          <a:bodyPr xmlns:a="http://schemas.openxmlformats.org/drawingml/2006/main"/>
-          <a:lstStyle xmlns:a="http://schemas.openxmlformats.org/drawingml/2006/main"/>
-          <a:p xmlns:a="http://schemas.openxmlformats.org/drawingml/2006/main"/>
+          <a:bodyPr/>
+          <a:lstStyle/>
+          <a:p>
+            <a:r>
+              <a:rPr lang="en-US"/>
+              <a:t>The quality gate makes standards executable.</a:t>
+            </a:r>
+          </a:p>
+          <a:p>
+            <a:r>
+              <a:rPr lang="en-US"/>
+              <a:t>Run `python3 scripts/check.py`. Point out the sequence: lint, harness doctor, docs checks, tests, and CLI smoke test.</a:t>
+            </a:r>
+          </a:p>
         </p:txBody>
       </p:sp>
       <p:sp>
         <p:nvSpPr>
           <p:cNvPr id="4" name="Slide Number Placeholder 3"/>
           <p:cNvSpPr>
-            <a:spLocks xmlns:a="http://schemas.openxmlformats.org/drawingml/2006/main" noGrp="1"/>
+            <a:spLocks noGrp="1"/>
           </p:cNvSpPr>
           <p:nvPr>
             <p:ph type="sldNum" idx="5"/>
@@ -976,21 +1064,21 @@
         </p:nvSpPr>
         <p:spPr/>
         <p:txBody>
-          <a:bodyPr xmlns:a="http://schemas.openxmlformats.org/drawingml/2006/main"/>
-          <a:lstStyle xmlns:a="http://schemas.openxmlformats.org/drawingml/2006/main"/>
-          <a:p xmlns:a="http://schemas.openxmlformats.org/drawingml/2006/main"/>
+          <a:bodyPr/>
+          <a:lstStyle/>
+          <a:p/>
         </p:txBody>
       </p:sp>
     </p:spTree>
   </p:cSld>
   <p:clrMapOvr>
-    <a:masterClrMapping xmlns:a="http://schemas.openxmlformats.org/drawingml/2006/main"/>
+    <a:masterClrMapping/>
   </p:clrMapOvr>
 </p:notes>
 </file>
 
 <file path=ppt/notesSlides/notesSlide7.xml><?xml version="1.0" encoding="utf-8"?>
-<p:notes xmlns:p="http://schemas.openxmlformats.org/presentationml/2006/main">
+<p:notes xmlns:a="http://schemas.openxmlformats.org/drawingml/2006/main" xmlns:p="http://schemas.openxmlformats.org/presentationml/2006/main">
   <p:cSld>
     <p:spTree>
       <p:nvGrpSpPr>
@@ -999,13 +1087,13 @@
         <p:nvPr/>
       </p:nvGrpSpPr>
       <p:grpSpPr>
-        <a:xfrm xmlns:a="http://schemas.openxmlformats.org/drawingml/2006/main"/>
+        <a:xfrm/>
       </p:grpSpPr>
       <p:sp>
         <p:nvSpPr>
           <p:cNvPr id="2" name="Slide Image Placeholder 1"/>
           <p:cNvSpPr>
-            <a:spLocks xmlns:a="http://schemas.openxmlformats.org/drawingml/2006/main" noGrp="1"/>
+            <a:spLocks noGrp="1"/>
           </p:cNvSpPr>
           <p:nvPr>
             <p:ph type="sldImg" idx="0"/>
@@ -1017,7 +1105,7 @@
         <p:nvSpPr>
           <p:cNvPr id="3" name="Notes Placeholder 2"/>
           <p:cNvSpPr>
-            <a:spLocks xmlns:a="http://schemas.openxmlformats.org/drawingml/2006/main" noGrp="1"/>
+            <a:spLocks noGrp="1"/>
           </p:cNvSpPr>
           <p:nvPr>
             <p:ph type="body" idx="1"/>
@@ -1025,16 +1113,27 @@
         </p:nvSpPr>
         <p:spPr/>
         <p:txBody>
-          <a:bodyPr xmlns:a="http://schemas.openxmlformats.org/drawingml/2006/main"/>
-          <a:lstStyle xmlns:a="http://schemas.openxmlformats.org/drawingml/2006/main"/>
-          <a:p xmlns:a="http://schemas.openxmlformats.org/drawingml/2006/main"/>
+          <a:bodyPr/>
+          <a:lstStyle/>
+          <a:p>
+            <a:r>
+              <a:rPr lang="en-US"/>
+              <a:t>Coding standards become rules, not wishes.</a:t>
+            </a:r>
+          </a:p>
+          <a:p>
+            <a:r>
+              <a:rPr lang="en-US"/>
+              <a:t>Use the CLI architecture rule as the concrete example. The standard says business rules belong in `TicketRouter`; the linter enforces that boundary.</a:t>
+            </a:r>
+          </a:p>
         </p:txBody>
       </p:sp>
       <p:sp>
         <p:nvSpPr>
           <p:cNvPr id="4" name="Slide Number Placeholder 3"/>
           <p:cNvSpPr>
-            <a:spLocks xmlns:a="http://schemas.openxmlformats.org/drawingml/2006/main" noGrp="1"/>
+            <a:spLocks noGrp="1"/>
           </p:cNvSpPr>
           <p:nvPr>
             <p:ph type="sldNum" idx="5"/>
@@ -1042,21 +1141,21 @@
         </p:nvSpPr>
         <p:spPr/>
         <p:txBody>
-          <a:bodyPr xmlns:a="http://schemas.openxmlformats.org/drawingml/2006/main"/>
-          <a:lstStyle xmlns:a="http://schemas.openxmlformats.org/drawingml/2006/main"/>
-          <a:p xmlns:a="http://schemas.openxmlformats.org/drawingml/2006/main"/>
+          <a:bodyPr/>
+          <a:lstStyle/>
+          <a:p/>
         </p:txBody>
       </p:sp>
     </p:spTree>
   </p:cSld>
   <p:clrMapOvr>
-    <a:masterClrMapping xmlns:a="http://schemas.openxmlformats.org/drawingml/2006/main"/>
+    <a:masterClrMapping/>
   </p:clrMapOvr>
 </p:notes>
 </file>
 
 <file path=ppt/notesSlides/notesSlide8.xml><?xml version="1.0" encoding="utf-8"?>
-<p:notes xmlns:p="http://schemas.openxmlformats.org/presentationml/2006/main">
+<p:notes xmlns:a="http://schemas.openxmlformats.org/drawingml/2006/main" xmlns:p="http://schemas.openxmlformats.org/presentationml/2006/main">
   <p:cSld>
     <p:spTree>
       <p:nvGrpSpPr>
@@ -1065,13 +1164,13 @@
         <p:nvPr/>
       </p:nvGrpSpPr>
       <p:grpSpPr>
-        <a:xfrm xmlns:a="http://schemas.openxmlformats.org/drawingml/2006/main"/>
+        <a:xfrm/>
       </p:grpSpPr>
       <p:sp>
         <p:nvSpPr>
           <p:cNvPr id="2" name="Slide Image Placeholder 1"/>
           <p:cNvSpPr>
-            <a:spLocks xmlns:a="http://schemas.openxmlformats.org/drawingml/2006/main" noGrp="1"/>
+            <a:spLocks noGrp="1"/>
           </p:cNvSpPr>
           <p:nvPr>
             <p:ph type="sldImg" idx="0"/>
@@ -1083,7 +1182,7 @@
         <p:nvSpPr>
           <p:cNvPr id="3" name="Notes Placeholder 2"/>
           <p:cNvSpPr>
-            <a:spLocks xmlns:a="http://schemas.openxmlformats.org/drawingml/2006/main" noGrp="1"/>
+            <a:spLocks noGrp="1"/>
           </p:cNvSpPr>
           <p:nvPr>
             <p:ph type="body" idx="1"/>
@@ -1091,16 +1190,27 @@
         </p:nvSpPr>
         <p:spPr/>
         <p:txBody>
-          <a:bodyPr xmlns:a="http://schemas.openxmlformats.org/drawingml/2006/main"/>
-          <a:lstStyle xmlns:a="http://schemas.openxmlformats.org/drawingml/2006/main"/>
-          <a:p xmlns:a="http://schemas.openxmlformats.org/drawingml/2006/main"/>
+          <a:bodyPr/>
+          <a:lstStyle/>
+          <a:p>
+            <a:r>
+              <a:rPr lang="en-US"/>
+              <a:t>The live demo should need only one short task prompt.</a:t>
+            </a:r>
+          </a:p>
+          <a:p>
+            <a:r>
+              <a:rPr lang="en-US"/>
+              <a:t>Use this prompt: `Complete tasks/01-add-sla-classification.md`. After the agent finishes, show `git diff` and run `python3 scripts/check.py`.</a:t>
+            </a:r>
+          </a:p>
         </p:txBody>
       </p:sp>
       <p:sp>
         <p:nvSpPr>
           <p:cNvPr id="4" name="Slide Number Placeholder 3"/>
           <p:cNvSpPr>
-            <a:spLocks xmlns:a="http://schemas.openxmlformats.org/drawingml/2006/main" noGrp="1"/>
+            <a:spLocks noGrp="1"/>
           </p:cNvSpPr>
           <p:nvPr>
             <p:ph type="sldNum" idx="5"/>
@@ -1108,21 +1218,21 @@
         </p:nvSpPr>
         <p:spPr/>
         <p:txBody>
-          <a:bodyPr xmlns:a="http://schemas.openxmlformats.org/drawingml/2006/main"/>
-          <a:lstStyle xmlns:a="http://schemas.openxmlformats.org/drawingml/2006/main"/>
-          <a:p xmlns:a="http://schemas.openxmlformats.org/drawingml/2006/main"/>
+          <a:bodyPr/>
+          <a:lstStyle/>
+          <a:p/>
         </p:txBody>
       </p:sp>
     </p:spTree>
   </p:cSld>
   <p:clrMapOvr>
-    <a:masterClrMapping xmlns:a="http://schemas.openxmlformats.org/drawingml/2006/main"/>
+    <a:masterClrMapping/>
   </p:clrMapOvr>
 </p:notes>
 </file>
 
 <file path=ppt/notesSlides/notesSlide9.xml><?xml version="1.0" encoding="utf-8"?>
-<p:notes xmlns:p="http://schemas.openxmlformats.org/presentationml/2006/main">
+<p:notes xmlns:a="http://schemas.openxmlformats.org/drawingml/2006/main" xmlns:p="http://schemas.openxmlformats.org/presentationml/2006/main">
   <p:cSld>
     <p:spTree>
       <p:nvGrpSpPr>
@@ -1131,13 +1241,13 @@
         <p:nvPr/>
       </p:nvGrpSpPr>
       <p:grpSpPr>
-        <a:xfrm xmlns:a="http://schemas.openxmlformats.org/drawingml/2006/main"/>
+        <a:xfrm/>
       </p:grpSpPr>
       <p:sp>
         <p:nvSpPr>
           <p:cNvPr id="2" name="Slide Image Placeholder 1"/>
           <p:cNvSpPr>
-            <a:spLocks xmlns:a="http://schemas.openxmlformats.org/drawingml/2006/main" noGrp="1"/>
+            <a:spLocks noGrp="1"/>
           </p:cNvSpPr>
           <p:nvPr>
             <p:ph type="sldImg" idx="0"/>
@@ -1149,7 +1259,7 @@
         <p:nvSpPr>
           <p:cNvPr id="3" name="Notes Placeholder 2"/>
           <p:cNvSpPr>
-            <a:spLocks xmlns:a="http://schemas.openxmlformats.org/drawingml/2006/main" noGrp="1"/>
+            <a:spLocks noGrp="1"/>
           </p:cNvSpPr>
           <p:nvPr>
             <p:ph type="body" idx="1"/>
@@ -1157,16 +1267,27 @@
         </p:nvSpPr>
         <p:spPr/>
         <p:txBody>
-          <a:bodyPr xmlns:a="http://schemas.openxmlformats.org/drawingml/2006/main"/>
-          <a:lstStyle xmlns:a="http://schemas.openxmlformats.org/drawingml/2006/main"/>
-          <a:p xmlns:a="http://schemas.openxmlformats.org/drawingml/2006/main"/>
+          <a:bodyPr/>
+          <a:lstStyle/>
+          <a:p>
+            <a:r>
+              <a:rPr lang="en-US"/>
+              <a:t>Failure is a feature when the harness catches drift.</a:t>
+            </a:r>
+          </a:p>
+          <a:p>
+            <a:r>
+              <a:rPr lang="en-US"/>
+              <a:t>Optional live moment: move `docs/runbook.md` temporarily and run the quality gate. Restore it afterwards. The point is that drift becomes visible.</a:t>
+            </a:r>
+          </a:p>
         </p:txBody>
       </p:sp>
       <p:sp>
         <p:nvSpPr>
           <p:cNvPr id="4" name="Slide Number Placeholder 3"/>
           <p:cNvSpPr>
-            <a:spLocks xmlns:a="http://schemas.openxmlformats.org/drawingml/2006/main" noGrp="1"/>
+            <a:spLocks noGrp="1"/>
           </p:cNvSpPr>
           <p:nvPr>
             <p:ph type="sldNum" idx="5"/>
@@ -1174,15 +1295,15 @@
         </p:nvSpPr>
         <p:spPr/>
         <p:txBody>
-          <a:bodyPr xmlns:a="http://schemas.openxmlformats.org/drawingml/2006/main"/>
-          <a:lstStyle xmlns:a="http://schemas.openxmlformats.org/drawingml/2006/main"/>
-          <a:p xmlns:a="http://schemas.openxmlformats.org/drawingml/2006/main"/>
+          <a:bodyPr/>
+          <a:lstStyle/>
+          <a:p/>
         </p:txBody>
       </p:sp>
     </p:spTree>
   </p:cSld>
   <p:clrMapOvr>
-    <a:masterClrMapping xmlns:a="http://schemas.openxmlformats.org/drawingml/2006/main"/>
+    <a:masterClrMapping/>
   </p:clrMapOvr>
 </p:notes>
 </file>

</xml_diff>

<commit_message>
Repair embedded speaker notes XML
</commit_message>
<xml_diff>
--- a/presentations/harness-engineering-workshop.pptx
+++ b/presentations/harness-engineering-workshop.pptx
@@ -462,7 +462,7 @@
 </file>
 
 <file path=ppt/notesSlides/notesSlide1.xml><?xml version="1.0" encoding="utf-8"?>
-<p:notes xmlns:a="http://schemas.openxmlformats.org/drawingml/2006/main" xmlns:p="http://schemas.openxmlformats.org/presentationml/2006/main">
+<p:notes xmlns:p="http://schemas.openxmlformats.org/presentationml/2006/main">
   <p:cSld>
     <p:spTree>
       <p:nvGrpSpPr>
@@ -471,13 +471,13 @@
         <p:nvPr/>
       </p:nvGrpSpPr>
       <p:grpSpPr>
-        <a:xfrm/>
+        <a:xfrm xmlns:a="http://schemas.openxmlformats.org/drawingml/2006/main"/>
       </p:grpSpPr>
       <p:sp>
         <p:nvSpPr>
           <p:cNvPr id="2" name="Slide Image Placeholder 1"/>
           <p:cNvSpPr>
-            <a:spLocks noGrp="1"/>
+            <a:spLocks xmlns:a="http://schemas.openxmlformats.org/drawingml/2006/main" noGrp="1"/>
           </p:cNvSpPr>
           <p:nvPr>
             <p:ph type="sldImg" idx="0"/>
@@ -489,7 +489,7 @@
         <p:nvSpPr>
           <p:cNvPr id="3" name="Notes Placeholder 2"/>
           <p:cNvSpPr>
-            <a:spLocks noGrp="1"/>
+            <a:spLocks xmlns:a="http://schemas.openxmlformats.org/drawingml/2006/main" noGrp="1"/>
           </p:cNvSpPr>
           <p:nvPr>
             <p:ph type="body" idx="1"/>
@@ -497,19 +497,21 @@
         </p:nvSpPr>
         <p:spPr/>
         <p:txBody>
-          <a:bodyPr/>
-          <a:lstStyle/>
-          <a:p>
-            <a:r>
-              <a:rPr lang="en-US"/>
+          <a:bodyPr xmlns:a="http://schemas.openxmlformats.org/drawingml/2006/main"/>
+          <a:lstStyle xmlns:a="http://schemas.openxmlformats.org/drawingml/2006/main"/>
+          <a:p xmlns:a="http://schemas.openxmlformats.org/drawingml/2006/main">
+            <a:r>
+              <a:rPr lang="en-US" dirty="0"/>
               <a:t>Harness engineering is the work around the agent.</a:t>
             </a:r>
-          </a:p>
-          <a:p>
-            <a:r>
-              <a:rPr lang="en-US"/>
+            <a:endParaRPr lang="en-US" dirty="0"/>
+          </a:p>
+          <a:p xmlns:a="http://schemas.openxmlformats.org/drawingml/2006/main">
+            <a:r>
+              <a:rPr lang="en-US" dirty="0"/>
               <a:t>Open by separating the model from the system around it. The agent may write the code, but the harness gives it context, tools, checks, and boundaries.</a:t>
             </a:r>
+            <a:endParaRPr lang="en-US" dirty="0"/>
           </a:p>
         </p:txBody>
       </p:sp>
@@ -517,7 +519,7 @@
         <p:nvSpPr>
           <p:cNvPr id="4" name="Slide Number Placeholder 3"/>
           <p:cNvSpPr>
-            <a:spLocks noGrp="1"/>
+            <a:spLocks xmlns:a="http://schemas.openxmlformats.org/drawingml/2006/main" noGrp="1"/>
           </p:cNvSpPr>
           <p:nvPr>
             <p:ph type="sldNum" idx="5"/>
@@ -525,21 +527,21 @@
         </p:nvSpPr>
         <p:spPr/>
         <p:txBody>
-          <a:bodyPr/>
-          <a:lstStyle/>
-          <a:p/>
+          <a:bodyPr xmlns:a="http://schemas.openxmlformats.org/drawingml/2006/main"/>
+          <a:lstStyle xmlns:a="http://schemas.openxmlformats.org/drawingml/2006/main"/>
+          <a:p xmlns:a="http://schemas.openxmlformats.org/drawingml/2006/main"/>
         </p:txBody>
       </p:sp>
     </p:spTree>
   </p:cSld>
   <p:clrMapOvr>
-    <a:masterClrMapping/>
+    <a:masterClrMapping xmlns:a="http://schemas.openxmlformats.org/drawingml/2006/main"/>
   </p:clrMapOvr>
 </p:notes>
 </file>
 
 <file path=ppt/notesSlides/notesSlide10.xml><?xml version="1.0" encoding="utf-8"?>
-<p:notes xmlns:a="http://schemas.openxmlformats.org/drawingml/2006/main" xmlns:p="http://schemas.openxmlformats.org/presentationml/2006/main">
+<p:notes xmlns:p="http://schemas.openxmlformats.org/presentationml/2006/main">
   <p:cSld>
     <p:spTree>
       <p:nvGrpSpPr>
@@ -548,13 +550,13 @@
         <p:nvPr/>
       </p:nvGrpSpPr>
       <p:grpSpPr>
-        <a:xfrm/>
+        <a:xfrm xmlns:a="http://schemas.openxmlformats.org/drawingml/2006/main"/>
       </p:grpSpPr>
       <p:sp>
         <p:nvSpPr>
           <p:cNvPr id="2" name="Slide Image Placeholder 1"/>
           <p:cNvSpPr>
-            <a:spLocks noGrp="1"/>
+            <a:spLocks xmlns:a="http://schemas.openxmlformats.org/drawingml/2006/main" noGrp="1"/>
           </p:cNvSpPr>
           <p:nvPr>
             <p:ph type="sldImg" idx="0"/>
@@ -566,7 +568,7 @@
         <p:nvSpPr>
           <p:cNvPr id="3" name="Notes Placeholder 2"/>
           <p:cNvSpPr>
-            <a:spLocks noGrp="1"/>
+            <a:spLocks xmlns:a="http://schemas.openxmlformats.org/drawingml/2006/main" noGrp="1"/>
           </p:cNvSpPr>
           <p:nvPr>
             <p:ph type="body" idx="1"/>
@@ -574,19 +576,21 @@
         </p:nvSpPr>
         <p:spPr/>
         <p:txBody>
-          <a:bodyPr/>
-          <a:lstStyle/>
-          <a:p>
-            <a:r>
-              <a:rPr lang="en-US"/>
+          <a:bodyPr xmlns:a="http://schemas.openxmlformats.org/drawingml/2006/main"/>
+          <a:lstStyle xmlns:a="http://schemas.openxmlformats.org/drawingml/2006/main"/>
+          <a:p xmlns:a="http://schemas.openxmlformats.org/drawingml/2006/main">
+            <a:r>
+              <a:rPr lang="en-US" dirty="0"/>
               <a:t>Build the harness in layers, not in one heroic rewrite.</a:t>
             </a:r>
-          </a:p>
-          <a:p>
-            <a:r>
-              <a:rPr lang="en-US"/>
+            <a:endParaRPr lang="en-US" dirty="0"/>
+          </a:p>
+          <a:p xmlns:a="http://schemas.openxmlformats.org/drawingml/2006/main">
+            <a:r>
+              <a:rPr lang="en-US" dirty="0"/>
               <a:t>Give the team a practical path: first instructions and one command, then CI and runbooks, then architecture checks and recurring cleanup.</a:t>
             </a:r>
+            <a:endParaRPr lang="en-US" dirty="0"/>
           </a:p>
         </p:txBody>
       </p:sp>
@@ -594,7 +598,7 @@
         <p:nvSpPr>
           <p:cNvPr id="4" name="Slide Number Placeholder 3"/>
           <p:cNvSpPr>
-            <a:spLocks noGrp="1"/>
+            <a:spLocks xmlns:a="http://schemas.openxmlformats.org/drawingml/2006/main" noGrp="1"/>
           </p:cNvSpPr>
           <p:nvPr>
             <p:ph type="sldNum" idx="5"/>
@@ -602,21 +606,21 @@
         </p:nvSpPr>
         <p:spPr/>
         <p:txBody>
-          <a:bodyPr/>
-          <a:lstStyle/>
-          <a:p/>
+          <a:bodyPr xmlns:a="http://schemas.openxmlformats.org/drawingml/2006/main"/>
+          <a:lstStyle xmlns:a="http://schemas.openxmlformats.org/drawingml/2006/main"/>
+          <a:p xmlns:a="http://schemas.openxmlformats.org/drawingml/2006/main"/>
         </p:txBody>
       </p:sp>
     </p:spTree>
   </p:cSld>
   <p:clrMapOvr>
-    <a:masterClrMapping/>
+    <a:masterClrMapping xmlns:a="http://schemas.openxmlformats.org/drawingml/2006/main"/>
   </p:clrMapOvr>
 </p:notes>
 </file>
 
 <file path=ppt/notesSlides/notesSlide11.xml><?xml version="1.0" encoding="utf-8"?>
-<p:notes xmlns:a="http://schemas.openxmlformats.org/drawingml/2006/main" xmlns:p="http://schemas.openxmlformats.org/presentationml/2006/main">
+<p:notes xmlns:p="http://schemas.openxmlformats.org/presentationml/2006/main">
   <p:cSld>
     <p:spTree>
       <p:nvGrpSpPr>
@@ -625,13 +629,13 @@
         <p:nvPr/>
       </p:nvGrpSpPr>
       <p:grpSpPr>
-        <a:xfrm/>
+        <a:xfrm xmlns:a="http://schemas.openxmlformats.org/drawingml/2006/main"/>
       </p:grpSpPr>
       <p:sp>
         <p:nvSpPr>
           <p:cNvPr id="2" name="Slide Image Placeholder 1"/>
           <p:cNvSpPr>
-            <a:spLocks noGrp="1"/>
+            <a:spLocks xmlns:a="http://schemas.openxmlformats.org/drawingml/2006/main" noGrp="1"/>
           </p:cNvSpPr>
           <p:nvPr>
             <p:ph type="sldImg" idx="0"/>
@@ -643,7 +647,7 @@
         <p:nvSpPr>
           <p:cNvPr id="3" name="Notes Placeholder 2"/>
           <p:cNvSpPr>
-            <a:spLocks noGrp="1"/>
+            <a:spLocks xmlns:a="http://schemas.openxmlformats.org/drawingml/2006/main" noGrp="1"/>
           </p:cNvSpPr>
           <p:nvPr>
             <p:ph type="body" idx="1"/>
@@ -651,19 +655,21 @@
         </p:nvSpPr>
         <p:spPr/>
         <p:txBody>
-          <a:bodyPr/>
-          <a:lstStyle/>
-          <a:p>
-            <a:r>
-              <a:rPr lang="en-US"/>
+          <a:bodyPr xmlns:a="http://schemas.openxmlformats.org/drawingml/2006/main"/>
+          <a:lstStyle xmlns:a="http://schemas.openxmlformats.org/drawingml/2006/main"/>
+          <a:p xmlns:a="http://schemas.openxmlformats.org/drawingml/2006/main">
+            <a:r>
+              <a:rPr lang="en-US" dirty="0"/>
               <a:t>Less prompt ritual. More engineering leverage.</a:t>
             </a:r>
-          </a:p>
-          <a:p>
-            <a:r>
-              <a:rPr lang="en-US"/>
+            <a:endParaRPr lang="en-US" dirty="0"/>
+          </a:p>
+          <a:p xmlns:a="http://schemas.openxmlformats.org/drawingml/2006/main">
+            <a:r>
+              <a:rPr lang="en-US" dirty="0"/>
               <a:t>Close with the operating principle: treat bad agent output as feedback about the harness. Improve the system, not just the prompt.</a:t>
             </a:r>
+            <a:endParaRPr lang="en-US" dirty="0"/>
           </a:p>
         </p:txBody>
       </p:sp>
@@ -671,7 +677,7 @@
         <p:nvSpPr>
           <p:cNvPr id="4" name="Slide Number Placeholder 3"/>
           <p:cNvSpPr>
-            <a:spLocks noGrp="1"/>
+            <a:spLocks xmlns:a="http://schemas.openxmlformats.org/drawingml/2006/main" noGrp="1"/>
           </p:cNvSpPr>
           <p:nvPr>
             <p:ph type="sldNum" idx="5"/>
@@ -679,21 +685,21 @@
         </p:nvSpPr>
         <p:spPr/>
         <p:txBody>
-          <a:bodyPr/>
-          <a:lstStyle/>
-          <a:p/>
+          <a:bodyPr xmlns:a="http://schemas.openxmlformats.org/drawingml/2006/main"/>
+          <a:lstStyle xmlns:a="http://schemas.openxmlformats.org/drawingml/2006/main"/>
+          <a:p xmlns:a="http://schemas.openxmlformats.org/drawingml/2006/main"/>
         </p:txBody>
       </p:sp>
     </p:spTree>
   </p:cSld>
   <p:clrMapOvr>
-    <a:masterClrMapping/>
+    <a:masterClrMapping xmlns:a="http://schemas.openxmlformats.org/drawingml/2006/main"/>
   </p:clrMapOvr>
 </p:notes>
 </file>
 
 <file path=ppt/notesSlides/notesSlide2.xml><?xml version="1.0" encoding="utf-8"?>
-<p:notes xmlns:a="http://schemas.openxmlformats.org/drawingml/2006/main" xmlns:p="http://schemas.openxmlformats.org/presentationml/2006/main">
+<p:notes xmlns:p="http://schemas.openxmlformats.org/presentationml/2006/main">
   <p:cSld>
     <p:spTree>
       <p:nvGrpSpPr>
@@ -702,13 +708,13 @@
         <p:nvPr/>
       </p:nvGrpSpPr>
       <p:grpSpPr>
-        <a:xfrm/>
+        <a:xfrm xmlns:a="http://schemas.openxmlformats.org/drawingml/2006/main"/>
       </p:grpSpPr>
       <p:sp>
         <p:nvSpPr>
           <p:cNvPr id="2" name="Slide Image Placeholder 1"/>
           <p:cNvSpPr>
-            <a:spLocks noGrp="1"/>
+            <a:spLocks xmlns:a="http://schemas.openxmlformats.org/drawingml/2006/main" noGrp="1"/>
           </p:cNvSpPr>
           <p:nvPr>
             <p:ph type="sldImg" idx="0"/>
@@ -720,7 +726,7 @@
         <p:nvSpPr>
           <p:cNvPr id="3" name="Notes Placeholder 2"/>
           <p:cNvSpPr>
-            <a:spLocks noGrp="1"/>
+            <a:spLocks xmlns:a="http://schemas.openxmlformats.org/drawingml/2006/main" noGrp="1"/>
           </p:cNvSpPr>
           <p:nvPr>
             <p:ph type="body" idx="1"/>
@@ -728,19 +734,21 @@
         </p:nvSpPr>
         <p:spPr/>
         <p:txBody>
-          <a:bodyPr/>
-          <a:lstStyle/>
-          <a:p>
-            <a:r>
-              <a:rPr lang="en-US"/>
+          <a:bodyPr xmlns:a="http://schemas.openxmlformats.org/drawingml/2006/main"/>
+          <a:lstStyle xmlns:a="http://schemas.openxmlformats.org/drawingml/2006/main"/>
+          <a:p xmlns:a="http://schemas.openxmlformats.org/drawingml/2006/main">
+            <a:r>
+              <a:rPr lang="en-US" dirty="0"/>
               <a:t>A harness gives an agent five kinds of traction.</a:t>
             </a:r>
-          </a:p>
-          <a:p>
-            <a:r>
-              <a:rPr lang="en-US"/>
+            <a:endParaRPr lang="en-US" dirty="0"/>
+          </a:p>
+          <a:p xmlns:a="http://schemas.openxmlformats.org/drawingml/2006/main">
+            <a:r>
+              <a:rPr lang="en-US" dirty="0"/>
               <a:t>Walk through the five layers: context, execution, feedback, governance, and memory. Emphasize that each layer reduces ambiguity for both humans and agents.</a:t>
             </a:r>
+            <a:endParaRPr lang="en-US" dirty="0"/>
           </a:p>
         </p:txBody>
       </p:sp>
@@ -748,7 +756,7 @@
         <p:nvSpPr>
           <p:cNvPr id="4" name="Slide Number Placeholder 3"/>
           <p:cNvSpPr>
-            <a:spLocks noGrp="1"/>
+            <a:spLocks xmlns:a="http://schemas.openxmlformats.org/drawingml/2006/main" noGrp="1"/>
           </p:cNvSpPr>
           <p:nvPr>
             <p:ph type="sldNum" idx="5"/>
@@ -756,21 +764,21 @@
         </p:nvSpPr>
         <p:spPr/>
         <p:txBody>
-          <a:bodyPr/>
-          <a:lstStyle/>
-          <a:p/>
+          <a:bodyPr xmlns:a="http://schemas.openxmlformats.org/drawingml/2006/main"/>
+          <a:lstStyle xmlns:a="http://schemas.openxmlformats.org/drawingml/2006/main"/>
+          <a:p xmlns:a="http://schemas.openxmlformats.org/drawingml/2006/main"/>
         </p:txBody>
       </p:sp>
     </p:spTree>
   </p:cSld>
   <p:clrMapOvr>
-    <a:masterClrMapping/>
+    <a:masterClrMapping xmlns:a="http://schemas.openxmlformats.org/drawingml/2006/main"/>
   </p:clrMapOvr>
 </p:notes>
 </file>
 
 <file path=ppt/notesSlides/notesSlide3.xml><?xml version="1.0" encoding="utf-8"?>
-<p:notes xmlns:a="http://schemas.openxmlformats.org/drawingml/2006/main" xmlns:p="http://schemas.openxmlformats.org/presentationml/2006/main">
+<p:notes xmlns:p="http://schemas.openxmlformats.org/presentationml/2006/main">
   <p:cSld>
     <p:spTree>
       <p:nvGrpSpPr>
@@ -779,13 +787,13 @@
         <p:nvPr/>
       </p:nvGrpSpPr>
       <p:grpSpPr>
-        <a:xfrm/>
+        <a:xfrm xmlns:a="http://schemas.openxmlformats.org/drawingml/2006/main"/>
       </p:grpSpPr>
       <p:sp>
         <p:nvSpPr>
           <p:cNvPr id="2" name="Slide Image Placeholder 1"/>
           <p:cNvSpPr>
-            <a:spLocks noGrp="1"/>
+            <a:spLocks xmlns:a="http://schemas.openxmlformats.org/drawingml/2006/main" noGrp="1"/>
           </p:cNvSpPr>
           <p:nvPr>
             <p:ph type="sldImg" idx="0"/>
@@ -797,7 +805,7 @@
         <p:nvSpPr>
           <p:cNvPr id="3" name="Notes Placeholder 2"/>
           <p:cNvSpPr>
-            <a:spLocks noGrp="1"/>
+            <a:spLocks xmlns:a="http://schemas.openxmlformats.org/drawingml/2006/main" noGrp="1"/>
           </p:cNvSpPr>
           <p:nvPr>
             <p:ph type="body" idx="1"/>
@@ -805,19 +813,21 @@
         </p:nvSpPr>
         <p:spPr/>
         <p:txBody>
-          <a:bodyPr/>
-          <a:lstStyle/>
-          <a:p>
-            <a:r>
-              <a:rPr lang="en-US"/>
+          <a:bodyPr xmlns:a="http://schemas.openxmlformats.org/drawingml/2006/main"/>
+          <a:lstStyle xmlns:a="http://schemas.openxmlformats.org/drawingml/2006/main"/>
+          <a:p xmlns:a="http://schemas.openxmlformats.org/drawingml/2006/main">
+            <a:r>
+              <a:rPr lang="en-US" dirty="0"/>
               <a:t>The prompt gets shorter as the harness gets stronger.</a:t>
             </a:r>
-          </a:p>
-          <a:p>
-            <a:r>
-              <a:rPr lang="en-US"/>
+            <a:endParaRPr lang="en-US" dirty="0"/>
+          </a:p>
+          <a:p xmlns:a="http://schemas.openxmlformats.org/drawingml/2006/main">
+            <a:r>
+              <a:rPr lang="en-US" dirty="0"/>
               <a:t>Say the goal clearly: durable instructions should move out of prompts and into the repo. The best demo prompt is simply `Complete tasks/01-add-sla-classification.md`.</a:t>
             </a:r>
+            <a:endParaRPr lang="en-US" dirty="0"/>
           </a:p>
         </p:txBody>
       </p:sp>
@@ -825,7 +835,7 @@
         <p:nvSpPr>
           <p:cNvPr id="4" name="Slide Number Placeholder 3"/>
           <p:cNvSpPr>
-            <a:spLocks noGrp="1"/>
+            <a:spLocks xmlns:a="http://schemas.openxmlformats.org/drawingml/2006/main" noGrp="1"/>
           </p:cNvSpPr>
           <p:nvPr>
             <p:ph type="sldNum" idx="5"/>
@@ -833,21 +843,21 @@
         </p:nvSpPr>
         <p:spPr/>
         <p:txBody>
-          <a:bodyPr/>
-          <a:lstStyle/>
-          <a:p/>
+          <a:bodyPr xmlns:a="http://schemas.openxmlformats.org/drawingml/2006/main"/>
+          <a:lstStyle xmlns:a="http://schemas.openxmlformats.org/drawingml/2006/main"/>
+          <a:p xmlns:a="http://schemas.openxmlformats.org/drawingml/2006/main"/>
         </p:txBody>
       </p:sp>
     </p:spTree>
   </p:cSld>
   <p:clrMapOvr>
-    <a:masterClrMapping/>
+    <a:masterClrMapping xmlns:a="http://schemas.openxmlformats.org/drawingml/2006/main"/>
   </p:clrMapOvr>
 </p:notes>
 </file>
 
 <file path=ppt/notesSlides/notesSlide4.xml><?xml version="1.0" encoding="utf-8"?>
-<p:notes xmlns:a="http://schemas.openxmlformats.org/drawingml/2006/main" xmlns:p="http://schemas.openxmlformats.org/presentationml/2006/main">
+<p:notes xmlns:p="http://schemas.openxmlformats.org/presentationml/2006/main">
   <p:cSld>
     <p:spTree>
       <p:nvGrpSpPr>
@@ -856,13 +866,13 @@
         <p:nvPr/>
       </p:nvGrpSpPr>
       <p:grpSpPr>
-        <a:xfrm/>
+        <a:xfrm xmlns:a="http://schemas.openxmlformats.org/drawingml/2006/main"/>
       </p:grpSpPr>
       <p:sp>
         <p:nvSpPr>
           <p:cNvPr id="2" name="Slide Image Placeholder 1"/>
           <p:cNvSpPr>
-            <a:spLocks noGrp="1"/>
+            <a:spLocks xmlns:a="http://schemas.openxmlformats.org/drawingml/2006/main" noGrp="1"/>
           </p:cNvSpPr>
           <p:nvPr>
             <p:ph type="sldImg" idx="0"/>
@@ -874,7 +884,7 @@
         <p:nvSpPr>
           <p:cNvPr id="3" name="Notes Placeholder 2"/>
           <p:cNvSpPr>
-            <a:spLocks noGrp="1"/>
+            <a:spLocks xmlns:a="http://schemas.openxmlformats.org/drawingml/2006/main" noGrp="1"/>
           </p:cNvSpPr>
           <p:nvPr>
             <p:ph type="body" idx="1"/>
@@ -882,19 +892,21 @@
         </p:nvSpPr>
         <p:spPr/>
         <p:txBody>
-          <a:bodyPr/>
-          <a:lstStyle/>
-          <a:p>
-            <a:r>
-              <a:rPr lang="en-US"/>
+          <a:bodyPr xmlns:a="http://schemas.openxmlformats.org/drawingml/2006/main"/>
+          <a:lstStyle xmlns:a="http://schemas.openxmlformats.org/drawingml/2006/main"/>
+          <a:p xmlns:a="http://schemas.openxmlformats.org/drawingml/2006/main">
+            <a:r>
+              <a:rPr lang="en-US" dirty="0"/>
               <a:t>Our demo repo keeps the app tiny and the harness visible.</a:t>
             </a:r>
-          </a:p>
-          <a:p>
-            <a:r>
-              <a:rPr lang="en-US"/>
+            <a:endParaRPr lang="en-US" dirty="0"/>
+          </a:p>
+          <a:p xmlns:a="http://schemas.openxmlformats.org/drawingml/2006/main">
+            <a:r>
+              <a:rPr lang="en-US" dirty="0"/>
               <a:t>Explain that the app is intentionally small: a ticket router. The repo is the teaching object because the harness is easy to inspect.</a:t>
             </a:r>
+            <a:endParaRPr lang="en-US" dirty="0"/>
           </a:p>
         </p:txBody>
       </p:sp>
@@ -902,7 +914,7 @@
         <p:nvSpPr>
           <p:cNvPr id="4" name="Slide Number Placeholder 3"/>
           <p:cNvSpPr>
-            <a:spLocks noGrp="1"/>
+            <a:spLocks xmlns:a="http://schemas.openxmlformats.org/drawingml/2006/main" noGrp="1"/>
           </p:cNvSpPr>
           <p:nvPr>
             <p:ph type="sldNum" idx="5"/>
@@ -910,21 +922,21 @@
         </p:nvSpPr>
         <p:spPr/>
         <p:txBody>
-          <a:bodyPr/>
-          <a:lstStyle/>
-          <a:p/>
+          <a:bodyPr xmlns:a="http://schemas.openxmlformats.org/drawingml/2006/main"/>
+          <a:lstStyle xmlns:a="http://schemas.openxmlformats.org/drawingml/2006/main"/>
+          <a:p xmlns:a="http://schemas.openxmlformats.org/drawingml/2006/main"/>
         </p:txBody>
       </p:sp>
     </p:spTree>
   </p:cSld>
   <p:clrMapOvr>
-    <a:masterClrMapping/>
+    <a:masterClrMapping xmlns:a="http://schemas.openxmlformats.org/drawingml/2006/main"/>
   </p:clrMapOvr>
 </p:notes>
 </file>
 
 <file path=ppt/notesSlides/notesSlide5.xml><?xml version="1.0" encoding="utf-8"?>
-<p:notes xmlns:a="http://schemas.openxmlformats.org/drawingml/2006/main" xmlns:p="http://schemas.openxmlformats.org/presentationml/2006/main">
+<p:notes xmlns:p="http://schemas.openxmlformats.org/presentationml/2006/main">
   <p:cSld>
     <p:spTree>
       <p:nvGrpSpPr>
@@ -933,13 +945,13 @@
         <p:nvPr/>
       </p:nvGrpSpPr>
       <p:grpSpPr>
-        <a:xfrm/>
+        <a:xfrm xmlns:a="http://schemas.openxmlformats.org/drawingml/2006/main"/>
       </p:grpSpPr>
       <p:sp>
         <p:nvSpPr>
           <p:cNvPr id="2" name="Slide Image Placeholder 1"/>
           <p:cNvSpPr>
-            <a:spLocks noGrp="1"/>
+            <a:spLocks xmlns:a="http://schemas.openxmlformats.org/drawingml/2006/main" noGrp="1"/>
           </p:cNvSpPr>
           <p:nvPr>
             <p:ph type="sldImg" idx="0"/>
@@ -951,7 +963,7 @@
         <p:nvSpPr>
           <p:cNvPr id="3" name="Notes Placeholder 2"/>
           <p:cNvSpPr>
-            <a:spLocks noGrp="1"/>
+            <a:spLocks xmlns:a="http://schemas.openxmlformats.org/drawingml/2006/main" noGrp="1"/>
           </p:cNvSpPr>
           <p:nvPr>
             <p:ph type="body" idx="1"/>
@@ -959,19 +971,21 @@
         </p:nvSpPr>
         <p:spPr/>
         <p:txBody>
-          <a:bodyPr/>
-          <a:lstStyle/>
-          <a:p>
-            <a:r>
-              <a:rPr lang="en-US"/>
+          <a:bodyPr xmlns:a="http://schemas.openxmlformats.org/drawingml/2006/main"/>
+          <a:lstStyle xmlns:a="http://schemas.openxmlformats.org/drawingml/2006/main"/>
+          <a:p xmlns:a="http://schemas.openxmlformats.org/drawingml/2006/main">
+            <a:r>
+              <a:rPr lang="en-US" dirty="0"/>
               <a:t>The harness tells the agent what to read and where to change code.</a:t>
             </a:r>
-          </a:p>
-          <a:p>
-            <a:r>
-              <a:rPr lang="en-US"/>
+            <a:endParaRPr lang="en-US" dirty="0"/>
+          </a:p>
+          <a:p xmlns:a="http://schemas.openxmlformats.org/drawingml/2006/main">
+            <a:r>
+              <a:rPr lang="en-US" dirty="0"/>
               <a:t>Show how the task brief, `AGENTS.md`, architecture docs, router, and tests form a path. This narrows the search space before the agent edits.</a:t>
             </a:r>
+            <a:endParaRPr lang="en-US" dirty="0"/>
           </a:p>
         </p:txBody>
       </p:sp>
@@ -979,7 +993,7 @@
         <p:nvSpPr>
           <p:cNvPr id="4" name="Slide Number Placeholder 3"/>
           <p:cNvSpPr>
-            <a:spLocks noGrp="1"/>
+            <a:spLocks xmlns:a="http://schemas.openxmlformats.org/drawingml/2006/main" noGrp="1"/>
           </p:cNvSpPr>
           <p:nvPr>
             <p:ph type="sldNum" idx="5"/>
@@ -987,21 +1001,21 @@
         </p:nvSpPr>
         <p:spPr/>
         <p:txBody>
-          <a:bodyPr/>
-          <a:lstStyle/>
-          <a:p/>
+          <a:bodyPr xmlns:a="http://schemas.openxmlformats.org/drawingml/2006/main"/>
+          <a:lstStyle xmlns:a="http://schemas.openxmlformats.org/drawingml/2006/main"/>
+          <a:p xmlns:a="http://schemas.openxmlformats.org/drawingml/2006/main"/>
         </p:txBody>
       </p:sp>
     </p:spTree>
   </p:cSld>
   <p:clrMapOvr>
-    <a:masterClrMapping/>
+    <a:masterClrMapping xmlns:a="http://schemas.openxmlformats.org/drawingml/2006/main"/>
   </p:clrMapOvr>
 </p:notes>
 </file>
 
 <file path=ppt/notesSlides/notesSlide6.xml><?xml version="1.0" encoding="utf-8"?>
-<p:notes xmlns:a="http://schemas.openxmlformats.org/drawingml/2006/main" xmlns:p="http://schemas.openxmlformats.org/presentationml/2006/main">
+<p:notes xmlns:p="http://schemas.openxmlformats.org/presentationml/2006/main">
   <p:cSld>
     <p:spTree>
       <p:nvGrpSpPr>
@@ -1010,13 +1024,13 @@
         <p:nvPr/>
       </p:nvGrpSpPr>
       <p:grpSpPr>
-        <a:xfrm/>
+        <a:xfrm xmlns:a="http://schemas.openxmlformats.org/drawingml/2006/main"/>
       </p:grpSpPr>
       <p:sp>
         <p:nvSpPr>
           <p:cNvPr id="2" name="Slide Image Placeholder 1"/>
           <p:cNvSpPr>
-            <a:spLocks noGrp="1"/>
+            <a:spLocks xmlns:a="http://schemas.openxmlformats.org/drawingml/2006/main" noGrp="1"/>
           </p:cNvSpPr>
           <p:nvPr>
             <p:ph type="sldImg" idx="0"/>
@@ -1028,7 +1042,7 @@
         <p:nvSpPr>
           <p:cNvPr id="3" name="Notes Placeholder 2"/>
           <p:cNvSpPr>
-            <a:spLocks noGrp="1"/>
+            <a:spLocks xmlns:a="http://schemas.openxmlformats.org/drawingml/2006/main" noGrp="1"/>
           </p:cNvSpPr>
           <p:nvPr>
             <p:ph type="body" idx="1"/>
@@ -1036,19 +1050,21 @@
         </p:nvSpPr>
         <p:spPr/>
         <p:txBody>
-          <a:bodyPr/>
-          <a:lstStyle/>
-          <a:p>
-            <a:r>
-              <a:rPr lang="en-US"/>
+          <a:bodyPr xmlns:a="http://schemas.openxmlformats.org/drawingml/2006/main"/>
+          <a:lstStyle xmlns:a="http://schemas.openxmlformats.org/drawingml/2006/main"/>
+          <a:p xmlns:a="http://schemas.openxmlformats.org/drawingml/2006/main">
+            <a:r>
+              <a:rPr lang="en-US" dirty="0"/>
               <a:t>The quality gate makes standards executable.</a:t>
             </a:r>
-          </a:p>
-          <a:p>
-            <a:r>
-              <a:rPr lang="en-US"/>
+            <a:endParaRPr lang="en-US" dirty="0"/>
+          </a:p>
+          <a:p xmlns:a="http://schemas.openxmlformats.org/drawingml/2006/main">
+            <a:r>
+              <a:rPr lang="en-US" dirty="0"/>
               <a:t>Run `python3 scripts/check.py`. Point out the sequence: lint, harness doctor, docs checks, tests, and CLI smoke test.</a:t>
             </a:r>
+            <a:endParaRPr lang="en-US" dirty="0"/>
           </a:p>
         </p:txBody>
       </p:sp>
@@ -1056,7 +1072,7 @@
         <p:nvSpPr>
           <p:cNvPr id="4" name="Slide Number Placeholder 3"/>
           <p:cNvSpPr>
-            <a:spLocks noGrp="1"/>
+            <a:spLocks xmlns:a="http://schemas.openxmlformats.org/drawingml/2006/main" noGrp="1"/>
           </p:cNvSpPr>
           <p:nvPr>
             <p:ph type="sldNum" idx="5"/>
@@ -1064,21 +1080,21 @@
         </p:nvSpPr>
         <p:spPr/>
         <p:txBody>
-          <a:bodyPr/>
-          <a:lstStyle/>
-          <a:p/>
+          <a:bodyPr xmlns:a="http://schemas.openxmlformats.org/drawingml/2006/main"/>
+          <a:lstStyle xmlns:a="http://schemas.openxmlformats.org/drawingml/2006/main"/>
+          <a:p xmlns:a="http://schemas.openxmlformats.org/drawingml/2006/main"/>
         </p:txBody>
       </p:sp>
     </p:spTree>
   </p:cSld>
   <p:clrMapOvr>
-    <a:masterClrMapping/>
+    <a:masterClrMapping xmlns:a="http://schemas.openxmlformats.org/drawingml/2006/main"/>
   </p:clrMapOvr>
 </p:notes>
 </file>
 
 <file path=ppt/notesSlides/notesSlide7.xml><?xml version="1.0" encoding="utf-8"?>
-<p:notes xmlns:a="http://schemas.openxmlformats.org/drawingml/2006/main" xmlns:p="http://schemas.openxmlformats.org/presentationml/2006/main">
+<p:notes xmlns:p="http://schemas.openxmlformats.org/presentationml/2006/main">
   <p:cSld>
     <p:spTree>
       <p:nvGrpSpPr>
@@ -1087,13 +1103,13 @@
         <p:nvPr/>
       </p:nvGrpSpPr>
       <p:grpSpPr>
-        <a:xfrm/>
+        <a:xfrm xmlns:a="http://schemas.openxmlformats.org/drawingml/2006/main"/>
       </p:grpSpPr>
       <p:sp>
         <p:nvSpPr>
           <p:cNvPr id="2" name="Slide Image Placeholder 1"/>
           <p:cNvSpPr>
-            <a:spLocks noGrp="1"/>
+            <a:spLocks xmlns:a="http://schemas.openxmlformats.org/drawingml/2006/main" noGrp="1"/>
           </p:cNvSpPr>
           <p:nvPr>
             <p:ph type="sldImg" idx="0"/>
@@ -1105,7 +1121,7 @@
         <p:nvSpPr>
           <p:cNvPr id="3" name="Notes Placeholder 2"/>
           <p:cNvSpPr>
-            <a:spLocks noGrp="1"/>
+            <a:spLocks xmlns:a="http://schemas.openxmlformats.org/drawingml/2006/main" noGrp="1"/>
           </p:cNvSpPr>
           <p:nvPr>
             <p:ph type="body" idx="1"/>
@@ -1113,19 +1129,21 @@
         </p:nvSpPr>
         <p:spPr/>
         <p:txBody>
-          <a:bodyPr/>
-          <a:lstStyle/>
-          <a:p>
-            <a:r>
-              <a:rPr lang="en-US"/>
+          <a:bodyPr xmlns:a="http://schemas.openxmlformats.org/drawingml/2006/main"/>
+          <a:lstStyle xmlns:a="http://schemas.openxmlformats.org/drawingml/2006/main"/>
+          <a:p xmlns:a="http://schemas.openxmlformats.org/drawingml/2006/main">
+            <a:r>
+              <a:rPr lang="en-US" dirty="0"/>
               <a:t>Coding standards become rules, not wishes.</a:t>
             </a:r>
-          </a:p>
-          <a:p>
-            <a:r>
-              <a:rPr lang="en-US"/>
+            <a:endParaRPr lang="en-US" dirty="0"/>
+          </a:p>
+          <a:p xmlns:a="http://schemas.openxmlformats.org/drawingml/2006/main">
+            <a:r>
+              <a:rPr lang="en-US" dirty="0"/>
               <a:t>Use the CLI architecture rule as the concrete example. The standard says business rules belong in `TicketRouter`; the linter enforces that boundary.</a:t>
             </a:r>
+            <a:endParaRPr lang="en-US" dirty="0"/>
           </a:p>
         </p:txBody>
       </p:sp>
@@ -1133,7 +1151,7 @@
         <p:nvSpPr>
           <p:cNvPr id="4" name="Slide Number Placeholder 3"/>
           <p:cNvSpPr>
-            <a:spLocks noGrp="1"/>
+            <a:spLocks xmlns:a="http://schemas.openxmlformats.org/drawingml/2006/main" noGrp="1"/>
           </p:cNvSpPr>
           <p:nvPr>
             <p:ph type="sldNum" idx="5"/>
@@ -1141,21 +1159,21 @@
         </p:nvSpPr>
         <p:spPr/>
         <p:txBody>
-          <a:bodyPr/>
-          <a:lstStyle/>
-          <a:p/>
+          <a:bodyPr xmlns:a="http://schemas.openxmlformats.org/drawingml/2006/main"/>
+          <a:lstStyle xmlns:a="http://schemas.openxmlformats.org/drawingml/2006/main"/>
+          <a:p xmlns:a="http://schemas.openxmlformats.org/drawingml/2006/main"/>
         </p:txBody>
       </p:sp>
     </p:spTree>
   </p:cSld>
   <p:clrMapOvr>
-    <a:masterClrMapping/>
+    <a:masterClrMapping xmlns:a="http://schemas.openxmlformats.org/drawingml/2006/main"/>
   </p:clrMapOvr>
 </p:notes>
 </file>
 
 <file path=ppt/notesSlides/notesSlide8.xml><?xml version="1.0" encoding="utf-8"?>
-<p:notes xmlns:a="http://schemas.openxmlformats.org/drawingml/2006/main" xmlns:p="http://schemas.openxmlformats.org/presentationml/2006/main">
+<p:notes xmlns:p="http://schemas.openxmlformats.org/presentationml/2006/main">
   <p:cSld>
     <p:spTree>
       <p:nvGrpSpPr>
@@ -1164,13 +1182,13 @@
         <p:nvPr/>
       </p:nvGrpSpPr>
       <p:grpSpPr>
-        <a:xfrm/>
+        <a:xfrm xmlns:a="http://schemas.openxmlformats.org/drawingml/2006/main"/>
       </p:grpSpPr>
       <p:sp>
         <p:nvSpPr>
           <p:cNvPr id="2" name="Slide Image Placeholder 1"/>
           <p:cNvSpPr>
-            <a:spLocks noGrp="1"/>
+            <a:spLocks xmlns:a="http://schemas.openxmlformats.org/drawingml/2006/main" noGrp="1"/>
           </p:cNvSpPr>
           <p:nvPr>
             <p:ph type="sldImg" idx="0"/>
@@ -1182,7 +1200,7 @@
         <p:nvSpPr>
           <p:cNvPr id="3" name="Notes Placeholder 2"/>
           <p:cNvSpPr>
-            <a:spLocks noGrp="1"/>
+            <a:spLocks xmlns:a="http://schemas.openxmlformats.org/drawingml/2006/main" noGrp="1"/>
           </p:cNvSpPr>
           <p:nvPr>
             <p:ph type="body" idx="1"/>
@@ -1190,19 +1208,21 @@
         </p:nvSpPr>
         <p:spPr/>
         <p:txBody>
-          <a:bodyPr/>
-          <a:lstStyle/>
-          <a:p>
-            <a:r>
-              <a:rPr lang="en-US"/>
+          <a:bodyPr xmlns:a="http://schemas.openxmlformats.org/drawingml/2006/main"/>
+          <a:lstStyle xmlns:a="http://schemas.openxmlformats.org/drawingml/2006/main"/>
+          <a:p xmlns:a="http://schemas.openxmlformats.org/drawingml/2006/main">
+            <a:r>
+              <a:rPr lang="en-US" dirty="0"/>
               <a:t>The live demo should need only one short task prompt.</a:t>
             </a:r>
-          </a:p>
-          <a:p>
-            <a:r>
-              <a:rPr lang="en-US"/>
+            <a:endParaRPr lang="en-US" dirty="0"/>
+          </a:p>
+          <a:p xmlns:a="http://schemas.openxmlformats.org/drawingml/2006/main">
+            <a:r>
+              <a:rPr lang="en-US" dirty="0"/>
               <a:t>Use this prompt: `Complete tasks/01-add-sla-classification.md`. After the agent finishes, show `git diff` and run `python3 scripts/check.py`.</a:t>
             </a:r>
+            <a:endParaRPr lang="en-US" dirty="0"/>
           </a:p>
         </p:txBody>
       </p:sp>
@@ -1210,7 +1230,7 @@
         <p:nvSpPr>
           <p:cNvPr id="4" name="Slide Number Placeholder 3"/>
           <p:cNvSpPr>
-            <a:spLocks noGrp="1"/>
+            <a:spLocks xmlns:a="http://schemas.openxmlformats.org/drawingml/2006/main" noGrp="1"/>
           </p:cNvSpPr>
           <p:nvPr>
             <p:ph type="sldNum" idx="5"/>
@@ -1218,21 +1238,21 @@
         </p:nvSpPr>
         <p:spPr/>
         <p:txBody>
-          <a:bodyPr/>
-          <a:lstStyle/>
-          <a:p/>
+          <a:bodyPr xmlns:a="http://schemas.openxmlformats.org/drawingml/2006/main"/>
+          <a:lstStyle xmlns:a="http://schemas.openxmlformats.org/drawingml/2006/main"/>
+          <a:p xmlns:a="http://schemas.openxmlformats.org/drawingml/2006/main"/>
         </p:txBody>
       </p:sp>
     </p:spTree>
   </p:cSld>
   <p:clrMapOvr>
-    <a:masterClrMapping/>
+    <a:masterClrMapping xmlns:a="http://schemas.openxmlformats.org/drawingml/2006/main"/>
   </p:clrMapOvr>
 </p:notes>
 </file>
 
 <file path=ppt/notesSlides/notesSlide9.xml><?xml version="1.0" encoding="utf-8"?>
-<p:notes xmlns:a="http://schemas.openxmlformats.org/drawingml/2006/main" xmlns:p="http://schemas.openxmlformats.org/presentationml/2006/main">
+<p:notes xmlns:p="http://schemas.openxmlformats.org/presentationml/2006/main">
   <p:cSld>
     <p:spTree>
       <p:nvGrpSpPr>
@@ -1241,13 +1261,13 @@
         <p:nvPr/>
       </p:nvGrpSpPr>
       <p:grpSpPr>
-        <a:xfrm/>
+        <a:xfrm xmlns:a="http://schemas.openxmlformats.org/drawingml/2006/main"/>
       </p:grpSpPr>
       <p:sp>
         <p:nvSpPr>
           <p:cNvPr id="2" name="Slide Image Placeholder 1"/>
           <p:cNvSpPr>
-            <a:spLocks noGrp="1"/>
+            <a:spLocks xmlns:a="http://schemas.openxmlformats.org/drawingml/2006/main" noGrp="1"/>
           </p:cNvSpPr>
           <p:nvPr>
             <p:ph type="sldImg" idx="0"/>
@@ -1259,7 +1279,7 @@
         <p:nvSpPr>
           <p:cNvPr id="3" name="Notes Placeholder 2"/>
           <p:cNvSpPr>
-            <a:spLocks noGrp="1"/>
+            <a:spLocks xmlns:a="http://schemas.openxmlformats.org/drawingml/2006/main" noGrp="1"/>
           </p:cNvSpPr>
           <p:nvPr>
             <p:ph type="body" idx="1"/>
@@ -1267,19 +1287,21 @@
         </p:nvSpPr>
         <p:spPr/>
         <p:txBody>
-          <a:bodyPr/>
-          <a:lstStyle/>
-          <a:p>
-            <a:r>
-              <a:rPr lang="en-US"/>
+          <a:bodyPr xmlns:a="http://schemas.openxmlformats.org/drawingml/2006/main"/>
+          <a:lstStyle xmlns:a="http://schemas.openxmlformats.org/drawingml/2006/main"/>
+          <a:p xmlns:a="http://schemas.openxmlformats.org/drawingml/2006/main">
+            <a:r>
+              <a:rPr lang="en-US" dirty="0"/>
               <a:t>Failure is a feature when the harness catches drift.</a:t>
             </a:r>
-          </a:p>
-          <a:p>
-            <a:r>
-              <a:rPr lang="en-US"/>
+            <a:endParaRPr lang="en-US" dirty="0"/>
+          </a:p>
+          <a:p xmlns:a="http://schemas.openxmlformats.org/drawingml/2006/main">
+            <a:r>
+              <a:rPr lang="en-US" dirty="0"/>
               <a:t>Optional live moment: move `docs/runbook.md` temporarily and run the quality gate. Restore it afterwards. The point is that drift becomes visible.</a:t>
             </a:r>
+            <a:endParaRPr lang="en-US" dirty="0"/>
           </a:p>
         </p:txBody>
       </p:sp>
@@ -1287,7 +1309,7 @@
         <p:nvSpPr>
           <p:cNvPr id="4" name="Slide Number Placeholder 3"/>
           <p:cNvSpPr>
-            <a:spLocks noGrp="1"/>
+            <a:spLocks xmlns:a="http://schemas.openxmlformats.org/drawingml/2006/main" noGrp="1"/>
           </p:cNvSpPr>
           <p:nvPr>
             <p:ph type="sldNum" idx="5"/>
@@ -1295,15 +1317,15 @@
         </p:nvSpPr>
         <p:spPr/>
         <p:txBody>
-          <a:bodyPr/>
-          <a:lstStyle/>
-          <a:p/>
+          <a:bodyPr xmlns:a="http://schemas.openxmlformats.org/drawingml/2006/main"/>
+          <a:lstStyle xmlns:a="http://schemas.openxmlformats.org/drawingml/2006/main"/>
+          <a:p xmlns:a="http://schemas.openxmlformats.org/drawingml/2006/main"/>
         </p:txBody>
       </p:sp>
     </p:spTree>
   </p:cSld>
   <p:clrMapOvr>
-    <a:masterClrMapping/>
+    <a:masterClrMapping xmlns:a="http://schemas.openxmlformats.org/drawingml/2006/main"/>
   </p:clrMapOvr>
 </p:notes>
 </file>

</xml_diff>

<commit_message>
Remove internal maturity score from deck
</commit_message>
<xml_diff>
--- a/presentations/harness-engineering-workshop.pptx
+++ b/presentations/harness-engineering-workshop.pptx
@@ -5028,7 +5028,7 @@
                 </a:solidFill>
                 <a:latin typeface="Aptos"/>
               </a:rPr>
-              <a:t>8/10</a:t>
+              <a:t>Context</a:t>
             </a:r>
           </a:p>
         </p:txBody>
@@ -5062,7 +5062,7 @@
                 </a:solidFill>
                 <a:latin typeface="Aptos"/>
               </a:rPr>
-              <a:t>target harness maturity</a:t>
+              <a:t>repo carries intent</a:t>
             </a:r>
           </a:p>
         </p:txBody>
@@ -7542,7 +7542,7 @@
                 </a:solidFill>
                 <a:latin typeface="Aptos"/>
               </a:rPr>
-              <a:t>runbook, scorecard, prompt recipes</a:t>
+              <a:t>runbook, ADRs, prompt recipes</a:t>
             </a:r>
           </a:p>
         </p:txBody>
@@ -9304,7 +9304,7 @@
                 </a:solidFill>
                 <a:latin typeface="Aptos"/>
               </a:rPr>
-              <a:t>architecture, scorecard, runbook, ADRs</a:t>
+              <a:t>architecture, runbook, ADRs</a:t>
             </a:r>
           </a:p>
         </p:txBody>

</xml_diff>

<commit_message>
Make workshop deck learner-facing
</commit_message>
<xml_diff>
--- a/presentations/harness-engineering-workshop.pptx
+++ b/presentations/harness-engineering-workshop.pptx
@@ -391,7 +391,7 @@
           <a:p>
             <a:r>
               <a:rPr lang="en-US" dirty="0"/>
-              <a:t>Build the harness in layers, not in one heroic rewrite.</a:t>
+              <a:t>Build the harness in layers.</a:t>
             </a:r>
           </a:p>
           <a:p>
@@ -4269,7 +4269,7 @@
                 </a:solidFill>
                 <a:latin typeface="Aptos Display"/>
               </a:rPr>
-              <a:t>Harness engineering is the work around the agent.</a:t>
+              <a:t>Harness engineering is the system around the agent.</a:t>
             </a:r>
           </a:p>
         </p:txBody>
@@ -5529,7 +5529,7 @@
                 </a:solidFill>
                 <a:latin typeface="Aptos Display"/>
               </a:rPr>
-              <a:t>Build the harness in layers, not in one heroic rewrite.</a:t>
+              <a:t>Build the harness in layers.</a:t>
             </a:r>
           </a:p>
         </p:txBody>
@@ -5563,7 +5563,7 @@
                 </a:solidFill>
                 <a:latin typeface="Aptos"/>
               </a:rPr>
-              <a:t>Start with instructions and checks, then add governance, memory, and richer feedback loops.</a:t>
+              <a:t>Start small: instructions and one check. Then add governance, memory, and richer feedback.</a:t>
             </a:r>
           </a:p>
         </p:txBody>
@@ -6368,7 +6368,7 @@
                 <a:latin typeface="Aptos Display"/>
               </a:rPr>
               <a:t>Less prompt ritual.
-More engineering leverage.</a:t>
+More reliable agent work.</a:t>
             </a:r>
           </a:p>
         </p:txBody>
@@ -6722,7 +6722,7 @@
                 </a:solidFill>
                 <a:latin typeface="Aptos"/>
               </a:rPr>
-              <a:t>Harness engineering makes agent use a team capability.</a:t>
+              <a:t>Harness engineering turns agent use into a team capability.</a:t>
             </a:r>
           </a:p>
         </p:txBody>
@@ -8333,7 +8333,7 @@
                 </a:solidFill>
                 <a:latin typeface="Aptos Display"/>
               </a:rPr>
-              <a:t>Our demo repo keeps the app tiny and the harness visible.</a:t>
+              <a:t>The demo repo keeps the app small and the harness visible.</a:t>
             </a:r>
           </a:p>
         </p:txBody>
@@ -8367,7 +8367,7 @@
                 </a:solidFill>
                 <a:latin typeface="Aptos"/>
               </a:rPr>
-              <a:t>The application is intentionally boring. The repository environment is the teaching object.</a:t>
+              <a:t>The application is intentionally small. The repository environment is the teaching object.</a:t>
             </a:r>
           </a:p>
         </p:txBody>
@@ -13296,7 +13296,7 @@
                 </a:solidFill>
                 <a:latin typeface="Aptos Display"/>
               </a:rPr>
-              <a:t>The live demo should need only one short task prompt.</a:t>
+              <a:t>Use one short task prompt in the live demo.</a:t>
             </a:r>
           </a:p>
         </p:txBody>
@@ -13330,7 +13330,7 @@
                 </a:solidFill>
                 <a:latin typeface="Aptos"/>
               </a:rPr>
-              <a:t>The point is not the ticket router. The point is that the repo carries the operating instructions.</a:t>
+              <a:t>Watch how the repo supplies the operating instructions.</a:t>
             </a:r>
           </a:p>
         </p:txBody>
@@ -14090,7 +14090,7 @@
                 </a:solidFill>
                 <a:latin typeface="Aptos Display"/>
               </a:rPr>
-              <a:t>Failure is a feature when the harness catches drift.</a:t>
+              <a:t>A good harness catches drift early.</a:t>
             </a:r>
           </a:p>
         </p:txBody>
@@ -14124,7 +14124,7 @@
                 </a:solidFill>
                 <a:latin typeface="Aptos"/>
               </a:rPr>
-              <a:t>A good harness fails early when context, docs, architecture, or behavior fall out of contract.</a:t>
+              <a:t>When context, docs, architecture, or behavior drift, the quality gate should fail locally.</a:t>
             </a:r>
           </a:p>
         </p:txBody>
@@ -14813,7 +14813,7 @@
                 </a:solidFill>
                 <a:latin typeface="Aptos"/>
               </a:rPr>
-              <a:t>The harness turns drift into a visible, local failure.</a:t>
+              <a:t>Drift becomes a visible, local failure.</a:t>
             </a:r>
           </a:p>
         </p:txBody>

</xml_diff>